<commit_message>
Rewrite manuscript as TiFS Commentary format
- Target journal: Trends in Food Science & Technology (IF 17.0)
- Article type: Commentary (max 5000 words, 5 figs/tables, 50 refs)
- New title: 'From factory to cup: Montmorillonite-based portable sachets
  as a consumer-side decaffeination paradigm'
- 8-section narrative structure (unmet need → science → device → challenges)
- 30 references (Vancouver), 2 tables, 3 figures in PPTX
- Highlights added (required by TiFS)
- Removes old Medical Hypotheses manuscript

Co-Authored-By: Tatsuki Onishi <bougtoir@gmail.com>
</commit_message>
<xml_diff>
--- a/montmorillonite_decaf/figures_tables.pptx
+++ b/montmorillonite_decaf/figures_tables.pptx
@@ -8,6 +8,8 @@
     <p:sldId id="256" r:id="rId7"/>
     <p:sldId id="257" r:id="rId8"/>
     <p:sldId id="258" r:id="rId9"/>
+    <p:sldId id="259" r:id="rId10"/>
+    <p:sldId id="260" r:id="rId11"/>
   </p:sldIdLst>
   <p:sldSz cx="12191695" cy="6858000" type="screen4x3"/>
   <p:notesSz cx="6858000" cy="9144000"/>
@@ -3115,8 +3117,8 @@
         </p:nvSpPr>
         <p:spPr>
           <a:xfrm>
-            <a:off x="457200" y="274320"/>
-            <a:ext cx="10972800" cy="731520"/>
+            <a:off x="457200" y="182880"/>
+            <a:ext cx="10972800" cy="640080"/>
           </a:xfrm>
           <a:prstGeom prst="rect">
             <a:avLst/>
@@ -3130,10 +3132,10 @@
           <a:lstStyle/>
           <a:p>
             <a:pPr algn="ctr">
-              <a:defRPr sz="1800" b="1"/>
+              <a:defRPr sz="1400" b="1"/>
             </a:pPr>
             <a:r>
-              <a:t>Figure 1. Schematic of MMT sachet decaffeination mechanism</a:t>
+              <a:t>Figure 1. Selectivity of MMT vs activated carbon for caffeine removal from green tea extract</a:t>
             </a:r>
           </a:p>
         </p:txBody>
@@ -3146,8 +3148,659 @@
         </p:nvSpPr>
         <p:spPr>
           <a:xfrm>
-            <a:off x="914400" y="2286000"/>
-            <a:ext cx="2286000" cy="1645920"/>
+            <a:off x="1828800" y="1371600"/>
+            <a:ext cx="4114800" cy="4572000"/>
+          </a:xfrm>
+          <a:prstGeom prst="rect">
+            <a:avLst/>
+          </a:prstGeom>
+          <a:solidFill>
+            <a:srgbClr val="E8F5E9"/>
+          </a:solidFill>
+        </p:spPr>
+        <p:style>
+          <a:lnRef idx="1">
+            <a:schemeClr val="accent1"/>
+          </a:lnRef>
+          <a:fillRef idx="3">
+            <a:schemeClr val="accent1"/>
+          </a:fillRef>
+          <a:effectRef idx="2">
+            <a:schemeClr val="accent1"/>
+          </a:effectRef>
+          <a:fontRef idx="minor">
+            <a:schemeClr val="lt1"/>
+          </a:fontRef>
+        </p:style>
+        <p:txBody>
+          <a:bodyPr rtlCol="0" anchor="ctr" wrap="square"/>
+          <a:lstStyle/>
+          <a:p>
+            <a:pPr algn="l">
+              <a:defRPr sz="1100"/>
+            </a:pPr>
+            <a:r>
+              <a:t>MONTMORILLONITE</a:t>
+            </a:r>
+            <a:br/>
+            <a:br/>
+            <a:r>
+              <a:t>Caffeine removal: 96.5%</a:t>
+            </a:r>
+            <a:br/>
+            <a:r>
+              <a:t>━━━━━━━━━━━━━━━━━━━━━━ ■</a:t>
+            </a:r>
+            <a:br/>
+            <a:br/>
+            <a:r>
+              <a:t>Catechin retention: &gt;95%</a:t>
+            </a:r>
+            <a:br/>
+            <a:r>
+              <a:t>━━━━━━━━━━━━━━━━━━━━━━ ■</a:t>
+            </a:r>
+            <a:br/>
+            <a:br/>
+            <a:r>
+              <a:t>Taste change: Minimal</a:t>
+            </a:r>
+            <a:br/>
+            <a:r>
+              <a:t>━━━━━━━━━━━━━━━━━━━━━━ ■</a:t>
+            </a:r>
+          </a:p>
+        </p:txBody>
+      </p:sp>
+      <p:sp>
+        <p:nvSpPr>
+          <p:cNvPr id="5" name="Rectangle 4"/>
+          <p:cNvSpPr/>
+          <p:nvPr/>
+        </p:nvSpPr>
+        <p:spPr>
+          <a:xfrm>
+            <a:off x="6400800" y="1371600"/>
+            <a:ext cx="4114800" cy="4572000"/>
+          </a:xfrm>
+          <a:prstGeom prst="rect">
+            <a:avLst/>
+          </a:prstGeom>
+          <a:solidFill>
+            <a:srgbClr val="FFEBEE"/>
+          </a:solidFill>
+        </p:spPr>
+        <p:style>
+          <a:lnRef idx="1">
+            <a:schemeClr val="accent1"/>
+          </a:lnRef>
+          <a:fillRef idx="3">
+            <a:schemeClr val="accent1"/>
+          </a:fillRef>
+          <a:effectRef idx="2">
+            <a:schemeClr val="accent1"/>
+          </a:effectRef>
+          <a:fontRef idx="minor">
+            <a:schemeClr val="lt1"/>
+          </a:fontRef>
+        </p:style>
+        <p:txBody>
+          <a:bodyPr rtlCol="0" anchor="ctr" wrap="square"/>
+          <a:lstStyle/>
+          <a:p>
+            <a:pPr algn="l">
+              <a:defRPr sz="1100"/>
+            </a:pPr>
+            <a:r>
+              <a:t>ACTIVATED CARBON</a:t>
+            </a:r>
+            <a:br/>
+            <a:br/>
+            <a:r>
+              <a:t>Caffeine removal: ~95%</a:t>
+            </a:r>
+            <a:br/>
+            <a:r>
+              <a:t>━━━━━━━━━━━━━━━━━━━━━━ ■</a:t>
+            </a:r>
+            <a:br/>
+            <a:br/>
+            <a:r>
+              <a:t>Catechin retention: LOW</a:t>
+            </a:r>
+            <a:br/>
+            <a:r>
+              <a:t>━━━━━━━━━━ ■</a:t>
+            </a:r>
+            <a:br/>
+            <a:br/>
+            <a:r>
+              <a:t>Taste change: Significant</a:t>
+            </a:r>
+            <a:br/>
+            <a:r>
+              <a:t>━━━━━━━━━━━━━━━━━━ ■</a:t>
+            </a:r>
+          </a:p>
+        </p:txBody>
+      </p:sp>
+      <p:sp>
+        <p:nvSpPr>
+          <p:cNvPr id="6" name="TextBox 5"/>
+          <p:cNvSpPr txBox="1"/>
+          <p:nvPr/>
+        </p:nvSpPr>
+        <p:spPr>
+          <a:xfrm>
+            <a:off x="457200" y="6126480"/>
+            <a:ext cx="10972800" cy="640080"/>
+          </a:xfrm>
+          <a:prstGeom prst="rect">
+            <a:avLst/>
+          </a:prstGeom>
+          <a:noFill/>
+        </p:spPr>
+        <p:txBody>
+          <a:bodyPr wrap="square">
+            <a:spAutoFit/>
+          </a:bodyPr>
+          <a:lstStyle/>
+          <a:p>
+            <a:pPr>
+              <a:defRPr sz="900" i="1"/>
+            </a:pPr>
+            <a:r>
+              <a:t>Data from Shiono et al. (2017). MMT selectively adsorbs caffeine while preserving catechins; activated carbon removes both non-selectively.</a:t>
+            </a:r>
+          </a:p>
+        </p:txBody>
+      </p:sp>
+    </p:spTree>
+  </p:cSld>
+  <p:clrMapOvr>
+    <a:masterClrMapping/>
+  </p:clrMapOvr>
+</p:sld>
+</file>
+
+<file path=ppt/slides/slide2.xml><?xml version="1.0" encoding="utf-8"?>
+<p:sld xmlns:a="http://schemas.openxmlformats.org/drawingml/2006/main" xmlns:p="http://schemas.openxmlformats.org/presentationml/2006/main" xmlns:r="http://schemas.openxmlformats.org/officeDocument/2006/relationships">
+  <p:cSld>
+    <p:spTree>
+      <p:nvGrpSpPr>
+        <p:cNvPr id="1" name=""/>
+        <p:cNvGrpSpPr/>
+        <p:nvPr/>
+      </p:nvGrpSpPr>
+      <p:grpSpPr/>
+      <p:sp>
+        <p:nvSpPr>
+          <p:cNvPr id="2" name="Title 1"/>
+          <p:cNvSpPr>
+            <a:spLocks noGrp="1"/>
+          </p:cNvSpPr>
+          <p:nvPr>
+            <p:ph type="title"/>
+          </p:nvPr>
+        </p:nvSpPr>
+        <p:spPr/>
+        <p:txBody>
+          <a:bodyPr/>
+          <a:lstStyle/>
+          <a:p/>
+        </p:txBody>
+      </p:sp>
+      <p:sp>
+        <p:nvSpPr>
+          <p:cNvPr id="3" name="TextBox 2"/>
+          <p:cNvSpPr txBox="1"/>
+          <p:nvPr/>
+        </p:nvSpPr>
+        <p:spPr>
+          <a:xfrm>
+            <a:off x="457200" y="182880"/>
+            <a:ext cx="10972800" cy="640080"/>
+          </a:xfrm>
+          <a:prstGeom prst="rect">
+            <a:avLst/>
+          </a:prstGeom>
+          <a:noFill/>
+        </p:spPr>
+        <p:txBody>
+          <a:bodyPr wrap="none">
+            <a:spAutoFit/>
+          </a:bodyPr>
+          <a:lstStyle/>
+          <a:p>
+            <a:pPr algn="ctr">
+              <a:defRPr sz="1400" b="1"/>
+            </a:pPr>
+            <a:r>
+              <a:t>Figure 2. Mechanism of selective caffeine adsorption by MMT</a:t>
+            </a:r>
+          </a:p>
+        </p:txBody>
+      </p:sp>
+      <p:sp>
+        <p:nvSpPr>
+          <p:cNvPr id="4" name="Rectangle 3"/>
+          <p:cNvSpPr/>
+          <p:nvPr/>
+        </p:nvSpPr>
+        <p:spPr>
+          <a:xfrm>
+            <a:off x="1371600" y="1371600"/>
+            <a:ext cx="9144000" cy="457200"/>
+          </a:xfrm>
+          <a:prstGeom prst="rect">
+            <a:avLst/>
+          </a:prstGeom>
+          <a:solidFill>
+            <a:srgbClr val="BF960A"/>
+          </a:solidFill>
+        </p:spPr>
+        <p:style>
+          <a:lnRef idx="1">
+            <a:schemeClr val="accent1"/>
+          </a:lnRef>
+          <a:fillRef idx="3">
+            <a:schemeClr val="accent1"/>
+          </a:fillRef>
+          <a:effectRef idx="2">
+            <a:schemeClr val="accent1"/>
+          </a:effectRef>
+          <a:fontRef idx="minor">
+            <a:schemeClr val="lt1"/>
+          </a:fontRef>
+        </p:style>
+        <p:txBody>
+          <a:bodyPr rtlCol="0" anchor="ctr"/>
+          <a:lstStyle/>
+          <a:p>
+            <a:pPr algn="ctr">
+              <a:defRPr sz="800">
+                <a:solidFill>
+                  <a:srgbClr val="FFFFFF"/>
+                </a:solidFill>
+              </a:defRPr>
+            </a:pPr>
+            <a:r>
+              <a:t>SiO₂ – Al₂O₃ – SiO₂ layer</a:t>
+            </a:r>
+          </a:p>
+        </p:txBody>
+      </p:sp>
+      <p:sp>
+        <p:nvSpPr>
+          <p:cNvPr id="5" name="Rectangle 4"/>
+          <p:cNvSpPr/>
+          <p:nvPr/>
+        </p:nvSpPr>
+        <p:spPr>
+          <a:xfrm>
+            <a:off x="1371600" y="2743200"/>
+            <a:ext cx="9144000" cy="457200"/>
+          </a:xfrm>
+          <a:prstGeom prst="rect">
+            <a:avLst/>
+          </a:prstGeom>
+          <a:solidFill>
+            <a:srgbClr val="BF960A"/>
+          </a:solidFill>
+        </p:spPr>
+        <p:style>
+          <a:lnRef idx="1">
+            <a:schemeClr val="accent1"/>
+          </a:lnRef>
+          <a:fillRef idx="3">
+            <a:schemeClr val="accent1"/>
+          </a:fillRef>
+          <a:effectRef idx="2">
+            <a:schemeClr val="accent1"/>
+          </a:effectRef>
+          <a:fontRef idx="minor">
+            <a:schemeClr val="lt1"/>
+          </a:fontRef>
+        </p:style>
+        <p:txBody>
+          <a:bodyPr rtlCol="0" anchor="ctr"/>
+          <a:lstStyle/>
+          <a:p>
+            <a:pPr algn="ctr">
+              <a:defRPr sz="800">
+                <a:solidFill>
+                  <a:srgbClr val="FFFFFF"/>
+                </a:solidFill>
+              </a:defRPr>
+            </a:pPr>
+            <a:r>
+              <a:t>SiO₂ – Al₂O₃ – SiO₂ layer</a:t>
+            </a:r>
+          </a:p>
+        </p:txBody>
+      </p:sp>
+      <p:sp>
+        <p:nvSpPr>
+          <p:cNvPr id="6" name="Rectangle 5"/>
+          <p:cNvSpPr/>
+          <p:nvPr/>
+        </p:nvSpPr>
+        <p:spPr>
+          <a:xfrm>
+            <a:off x="1371600" y="4114800"/>
+            <a:ext cx="9144000" cy="457200"/>
+          </a:xfrm>
+          <a:prstGeom prst="rect">
+            <a:avLst/>
+          </a:prstGeom>
+          <a:solidFill>
+            <a:srgbClr val="BF960A"/>
+          </a:solidFill>
+        </p:spPr>
+        <p:style>
+          <a:lnRef idx="1">
+            <a:schemeClr val="accent1"/>
+          </a:lnRef>
+          <a:fillRef idx="3">
+            <a:schemeClr val="accent1"/>
+          </a:fillRef>
+          <a:effectRef idx="2">
+            <a:schemeClr val="accent1"/>
+          </a:effectRef>
+          <a:fontRef idx="minor">
+            <a:schemeClr val="lt1"/>
+          </a:fontRef>
+        </p:style>
+        <p:txBody>
+          <a:bodyPr rtlCol="0" anchor="ctr"/>
+          <a:lstStyle/>
+          <a:p>
+            <a:pPr algn="ctr">
+              <a:defRPr sz="800">
+                <a:solidFill>
+                  <a:srgbClr val="FFFFFF"/>
+                </a:solidFill>
+              </a:defRPr>
+            </a:pPr>
+            <a:r>
+              <a:t>SiO₂ – Al₂O₃ – SiO₂ layer</a:t>
+            </a:r>
+          </a:p>
+        </p:txBody>
+      </p:sp>
+      <p:sp>
+        <p:nvSpPr>
+          <p:cNvPr id="7" name="Rectangle 6"/>
+          <p:cNvSpPr/>
+          <p:nvPr/>
+        </p:nvSpPr>
+        <p:spPr>
+          <a:xfrm>
+            <a:off x="1371600" y="5486400"/>
+            <a:ext cx="9144000" cy="457200"/>
+          </a:xfrm>
+          <a:prstGeom prst="rect">
+            <a:avLst/>
+          </a:prstGeom>
+          <a:solidFill>
+            <a:srgbClr val="BF960A"/>
+          </a:solidFill>
+        </p:spPr>
+        <p:style>
+          <a:lnRef idx="1">
+            <a:schemeClr val="accent1"/>
+          </a:lnRef>
+          <a:fillRef idx="3">
+            <a:schemeClr val="accent1"/>
+          </a:fillRef>
+          <a:effectRef idx="2">
+            <a:schemeClr val="accent1"/>
+          </a:effectRef>
+          <a:fontRef idx="minor">
+            <a:schemeClr val="lt1"/>
+          </a:fontRef>
+        </p:style>
+        <p:txBody>
+          <a:bodyPr rtlCol="0" anchor="ctr"/>
+          <a:lstStyle/>
+          <a:p>
+            <a:pPr algn="ctr">
+              <a:defRPr sz="800">
+                <a:solidFill>
+                  <a:srgbClr val="FFFFFF"/>
+                </a:solidFill>
+              </a:defRPr>
+            </a:pPr>
+            <a:r>
+              <a:t>SiO₂ – Al₂O₃ – SiO₂ layer</a:t>
+            </a:r>
+          </a:p>
+        </p:txBody>
+      </p:sp>
+      <p:sp>
+        <p:nvSpPr>
+          <p:cNvPr id="8" name="TextBox 7"/>
+          <p:cNvSpPr txBox="1"/>
+          <p:nvPr/>
+        </p:nvSpPr>
+        <p:spPr>
+          <a:xfrm>
+            <a:off x="1828800" y="1920240"/>
+            <a:ext cx="2743200" cy="548640"/>
+          </a:xfrm>
+          <a:prstGeom prst="rect">
+            <a:avLst/>
+          </a:prstGeom>
+          <a:noFill/>
+        </p:spPr>
+        <p:txBody>
+          <a:bodyPr wrap="none">
+            <a:spAutoFit/>
+          </a:bodyPr>
+          <a:lstStyle/>
+          <a:p>
+            <a:pPr>
+              <a:defRPr sz="900">
+                <a:solidFill>
+                  <a:srgbClr val="D32F2F"/>
+                </a:solidFill>
+              </a:defRPr>
+            </a:pPr>
+            <a:r>
+              <a:t>Interlayer: Cation⁺ + Caffeine</a:t>
+            </a:r>
+          </a:p>
+        </p:txBody>
+      </p:sp>
+      <p:sp>
+        <p:nvSpPr>
+          <p:cNvPr id="9" name="TextBox 8"/>
+          <p:cNvSpPr txBox="1"/>
+          <p:nvPr/>
+        </p:nvSpPr>
+        <p:spPr>
+          <a:xfrm>
+            <a:off x="1828800" y="3291840"/>
+            <a:ext cx="2743200" cy="548640"/>
+          </a:xfrm>
+          <a:prstGeom prst="rect">
+            <a:avLst/>
+          </a:prstGeom>
+          <a:noFill/>
+        </p:spPr>
+        <p:txBody>
+          <a:bodyPr wrap="none">
+            <a:spAutoFit/>
+          </a:bodyPr>
+          <a:lstStyle/>
+          <a:p>
+            <a:pPr>
+              <a:defRPr sz="900">
+                <a:solidFill>
+                  <a:srgbClr val="D32F2F"/>
+                </a:solidFill>
+              </a:defRPr>
+            </a:pPr>
+            <a:r>
+              <a:t>Interlayer: Cation⁺ + Caffeine</a:t>
+            </a:r>
+          </a:p>
+        </p:txBody>
+      </p:sp>
+      <p:sp>
+        <p:nvSpPr>
+          <p:cNvPr id="10" name="TextBox 9"/>
+          <p:cNvSpPr txBox="1"/>
+          <p:nvPr/>
+        </p:nvSpPr>
+        <p:spPr>
+          <a:xfrm>
+            <a:off x="1828800" y="4663440"/>
+            <a:ext cx="2743200" cy="548640"/>
+          </a:xfrm>
+          <a:prstGeom prst="rect">
+            <a:avLst/>
+          </a:prstGeom>
+          <a:noFill/>
+        </p:spPr>
+        <p:txBody>
+          <a:bodyPr wrap="none">
+            <a:spAutoFit/>
+          </a:bodyPr>
+          <a:lstStyle/>
+          <a:p>
+            <a:pPr>
+              <a:defRPr sz="900">
+                <a:solidFill>
+                  <a:srgbClr val="D32F2F"/>
+                </a:solidFill>
+              </a:defRPr>
+            </a:pPr>
+            <a:r>
+              <a:t>Interlayer: Cation⁺ + Caffeine</a:t>
+            </a:r>
+          </a:p>
+        </p:txBody>
+      </p:sp>
+      <p:sp>
+        <p:nvSpPr>
+          <p:cNvPr id="11" name="TextBox 10"/>
+          <p:cNvSpPr txBox="1"/>
+          <p:nvPr/>
+        </p:nvSpPr>
+        <p:spPr>
+          <a:xfrm>
+            <a:off x="5943600" y="1920240"/>
+            <a:ext cx="4572000" cy="1371600"/>
+          </a:xfrm>
+          <a:prstGeom prst="rect">
+            <a:avLst/>
+          </a:prstGeom>
+          <a:noFill/>
+        </p:spPr>
+        <p:txBody>
+          <a:bodyPr wrap="square">
+            <a:spAutoFit/>
+          </a:bodyPr>
+          <a:lstStyle/>
+          <a:p>
+            <a:pPr>
+              <a:defRPr sz="1000" b="1">
+                <a:solidFill>
+                  <a:srgbClr val="2E7D32"/>
+                </a:solidFill>
+              </a:defRPr>
+            </a:pPr>
+            <a:r>
+              <a:t>Polyphenols (MW 290–868 Da)</a:t>
+            </a:r>
+            <a:br/>
+            <a:r>
+              <a:t>→ STERICALLY EXCLUDED</a:t>
+            </a:r>
+            <a:br/>
+            <a:r>
+              <a:t>→ Remain in solution</a:t>
+            </a:r>
+          </a:p>
+        </p:txBody>
+      </p:sp>
+    </p:spTree>
+  </p:cSld>
+  <p:clrMapOvr>
+    <a:masterClrMapping/>
+  </p:clrMapOvr>
+</p:sld>
+</file>
+
+<file path=ppt/slides/slide3.xml><?xml version="1.0" encoding="utf-8"?>
+<p:sld xmlns:a="http://schemas.openxmlformats.org/drawingml/2006/main" xmlns:p="http://schemas.openxmlformats.org/presentationml/2006/main" xmlns:r="http://schemas.openxmlformats.org/officeDocument/2006/relationships">
+  <p:cSld>
+    <p:spTree>
+      <p:nvGrpSpPr>
+        <p:cNvPr id="1" name=""/>
+        <p:cNvGrpSpPr/>
+        <p:nvPr/>
+      </p:nvGrpSpPr>
+      <p:grpSpPr/>
+      <p:sp>
+        <p:nvSpPr>
+          <p:cNvPr id="2" name="Title 1"/>
+          <p:cNvSpPr>
+            <a:spLocks noGrp="1"/>
+          </p:cNvSpPr>
+          <p:nvPr>
+            <p:ph type="title"/>
+          </p:nvPr>
+        </p:nvSpPr>
+        <p:spPr/>
+        <p:txBody>
+          <a:bodyPr/>
+          <a:lstStyle/>
+          <a:p/>
+        </p:txBody>
+      </p:sp>
+      <p:sp>
+        <p:nvSpPr>
+          <p:cNvPr id="3" name="TextBox 2"/>
+          <p:cNvSpPr txBox="1"/>
+          <p:nvPr/>
+        </p:nvSpPr>
+        <p:spPr>
+          <a:xfrm>
+            <a:off x="457200" y="182880"/>
+            <a:ext cx="10972800" cy="640080"/>
+          </a:xfrm>
+          <a:prstGeom prst="rect">
+            <a:avLst/>
+          </a:prstGeom>
+          <a:noFill/>
+        </p:spPr>
+        <p:txBody>
+          <a:bodyPr wrap="none">
+            <a:spAutoFit/>
+          </a:bodyPr>
+          <a:lstStyle/>
+          <a:p>
+            <a:pPr algn="ctr">
+              <a:defRPr sz="1400" b="1"/>
+            </a:pPr>
+            <a:r>
+              <a:t>Figure 3. Consumer protocol for portable MMT decaffeination sachet</a:t>
+            </a:r>
+          </a:p>
+        </p:txBody>
+      </p:sp>
+      <p:sp>
+        <p:nvSpPr>
+          <p:cNvPr id="4" name="Rectangle 3"/>
+          <p:cNvSpPr/>
+          <p:nvPr/>
+        </p:nvSpPr>
+        <p:spPr>
+          <a:xfrm>
+            <a:off x="914400" y="1371600"/>
+            <a:ext cx="3200400" cy="4114800"/>
           </a:xfrm>
           <a:prstGeom prst="rect">
             <a:avLst/>
@@ -3175,14 +3828,19 @@
           <a:lstStyle/>
           <a:p>
             <a:pPr algn="ctr">
-              <a:defRPr sz="1200"/>
+              <a:defRPr sz="1400"/>
             </a:pPr>
             <a:r>
-              <a:t>Caffeinated</a:t>
+              <a:t>① IMMERSE</a:t>
             </a:r>
             <a:br/>
-            <a:r>
-              <a:t>Beverage</a:t>
+            <a:br/>
+            <a:r>
+              <a:t>Drop sachet into</a:t>
+            </a:r>
+            <a:br/>
+            <a:r>
+              <a:t>any caffeinated beverage</a:t>
             </a:r>
           </a:p>
         </p:txBody>
@@ -3195,8 +3853,8 @@
         </p:nvSpPr>
         <p:spPr>
           <a:xfrm>
-            <a:off x="4114800" y="2286000"/>
-            <a:ext cx="2286000" cy="1645920"/>
+            <a:off x="4114800" y="1371600"/>
+            <a:ext cx="3200400" cy="4114800"/>
           </a:xfrm>
           <a:prstGeom prst="rect">
             <a:avLst/>
@@ -3224,18 +3882,19 @@
           <a:lstStyle/>
           <a:p>
             <a:pPr algn="ctr">
-              <a:defRPr sz="1200"/>
+              <a:defRPr sz="1400"/>
             </a:pPr>
             <a:r>
-              <a:t>MMT Sachet</a:t>
+              <a:t>② WAIT 3–5 min</a:t>
             </a:r>
             <a:br/>
-            <a:r>
-              <a:t>Immersion</a:t>
-            </a:r>
             <a:br/>
             <a:r>
-              <a:t>(3-5 min)</a:t>
+              <a:t>Gentle agitation</a:t>
+            </a:r>
+            <a:br/>
+            <a:r>
+              <a:t>(like a tea bag)</a:t>
             </a:r>
           </a:p>
         </p:txBody>
@@ -3248,61 +3907,8 @@
         </p:nvSpPr>
         <p:spPr>
           <a:xfrm>
-            <a:off x="7315200" y="2286000"/>
-            <a:ext cx="2286000" cy="1645920"/>
-          </a:xfrm>
-          <a:prstGeom prst="rect">
-            <a:avLst/>
-          </a:prstGeom>
-          <a:solidFill>
-            <a:srgbClr val="FCE4EC"/>
-          </a:solidFill>
-        </p:spPr>
-        <p:style>
-          <a:lnRef idx="1">
-            <a:schemeClr val="accent1"/>
-          </a:lnRef>
-          <a:fillRef idx="3">
-            <a:schemeClr val="accent1"/>
-          </a:fillRef>
-          <a:effectRef idx="2">
-            <a:schemeClr val="accent1"/>
-          </a:effectRef>
-          <a:fontRef idx="minor">
-            <a:schemeClr val="lt1"/>
-          </a:fontRef>
-        </p:style>
-        <p:txBody>
-          <a:bodyPr rtlCol="0" anchor="ctr" wrap="square"/>
-          <a:lstStyle/>
-          <a:p>
-            <a:pPr algn="ctr">
-              <a:defRPr sz="1200"/>
-            </a:pPr>
-            <a:r>
-              <a:t>Caffeine</a:t>
-            </a:r>
-            <a:br/>
-            <a:r>
-              <a:t>Intercalation</a:t>
-            </a:r>
-            <a:br/>
-            <a:r>
-              <a:t>into MMT layers</a:t>
-            </a:r>
-          </a:p>
-        </p:txBody>
-      </p:sp>
-      <p:sp>
-        <p:nvSpPr>
-          <p:cNvPr id="7" name="Rectangle 6"/>
-          <p:cNvSpPr/>
-          <p:nvPr/>
-        </p:nvSpPr>
-        <p:spPr>
-          <a:xfrm>
-            <a:off x="10058400" y="2286000"/>
-            <a:ext cx="2286000" cy="1645920"/>
+            <a:off x="7315200" y="1371600"/>
+            <a:ext cx="3200400" cy="4114800"/>
           </a:xfrm>
           <a:prstGeom prst="rect">
             <a:avLst/>
@@ -3330,36 +3936,33 @@
           <a:lstStyle/>
           <a:p>
             <a:pPr algn="ctr">
-              <a:defRPr sz="1200"/>
+              <a:defRPr sz="1400"/>
             </a:pPr>
             <a:r>
-              <a:t>Decaffeinated</a:t>
+              <a:t>③ REMOVE</a:t>
             </a:r>
             <a:br/>
-            <a:r>
-              <a:t>Beverage</a:t>
-            </a:r>
             <a:br/>
             <a:r>
-              <a:t>(polyphenols</a:t>
+              <a:t>Discard sachet</a:t>
             </a:r>
             <a:br/>
             <a:r>
-              <a:t>preserved)</a:t>
-            </a:r>
-          </a:p>
-        </p:txBody>
-      </p:sp>
-      <p:sp>
-        <p:nvSpPr>
-          <p:cNvPr id="8" name="Can 7"/>
+              <a:t>→ Enjoy decaf!</a:t>
+            </a:r>
+          </a:p>
+        </p:txBody>
+      </p:sp>
+      <p:sp>
+        <p:nvSpPr>
+          <p:cNvPr id="7" name="Can 6"/>
           <p:cNvSpPr/>
           <p:nvPr/>
         </p:nvSpPr>
         <p:spPr>
           <a:xfrm>
-            <a:off x="3200400" y="2926080"/>
-            <a:ext cx="914400" cy="91440"/>
+            <a:off x="3657600" y="3200400"/>
+            <a:ext cx="457200" cy="91440"/>
           </a:xfrm>
           <a:prstGeom prst="can">
             <a:avLst/>
@@ -3392,14 +3995,14 @@
       </p:sp>
       <p:sp>
         <p:nvSpPr>
-          <p:cNvPr id="9" name="Can 8"/>
+          <p:cNvPr id="8" name="Can 7"/>
           <p:cNvSpPr/>
           <p:nvPr/>
         </p:nvSpPr>
         <p:spPr>
           <a:xfrm>
-            <a:off x="6400800" y="2926080"/>
-            <a:ext cx="914400" cy="91440"/>
+            <a:off x="6858000" y="3200400"/>
+            <a:ext cx="457200" cy="91440"/>
           </a:xfrm>
           <a:prstGeom prst="can">
             <a:avLst/>
@@ -3432,54 +4035,14 @@
       </p:sp>
       <p:sp>
         <p:nvSpPr>
-          <p:cNvPr id="10" name="Can 9"/>
-          <p:cNvSpPr/>
+          <p:cNvPr id="9" name="TextBox 8"/>
+          <p:cNvSpPr txBox="1"/>
           <p:nvPr/>
         </p:nvSpPr>
         <p:spPr>
           <a:xfrm>
-            <a:off x="9601200" y="2926080"/>
-            <a:ext cx="914400" cy="91440"/>
-          </a:xfrm>
-          <a:prstGeom prst="can">
-            <a:avLst/>
-          </a:prstGeom>
-          <a:solidFill>
-            <a:srgbClr val="424242"/>
-          </a:solidFill>
-        </p:spPr>
-        <p:style>
-          <a:lnRef idx="1">
-            <a:schemeClr val="accent1"/>
-          </a:lnRef>
-          <a:fillRef idx="3">
-            <a:schemeClr val="accent1"/>
-          </a:fillRef>
-          <a:effectRef idx="2">
-            <a:schemeClr val="accent1"/>
-          </a:effectRef>
-          <a:fontRef idx="minor">
-            <a:schemeClr val="lt1"/>
-          </a:fontRef>
-        </p:style>
-        <p:txBody>
-          <a:bodyPr rtlCol="0" anchor="ctr"/>
-          <a:lstStyle/>
-          <a:p>
-            <a:pPr algn="ctr"/>
-          </a:p>
-        </p:txBody>
-      </p:sp>
-      <p:sp>
-        <p:nvSpPr>
-          <p:cNvPr id="11" name="TextBox 10"/>
-          <p:cNvSpPr txBox="1"/>
-          <p:nvPr/>
-        </p:nvSpPr>
-        <p:spPr>
-          <a:xfrm>
-            <a:off x="457200" y="5029200"/>
-            <a:ext cx="10972800" cy="1371600"/>
+            <a:off x="1371600" y="5760720"/>
+            <a:ext cx="9144000" cy="914400"/>
           </a:xfrm>
           <a:prstGeom prst="rect">
             <a:avLst/>
@@ -3492,11 +4055,11 @@
           </a:bodyPr>
           <a:lstStyle/>
           <a:p>
-            <a:pPr algn="l">
-              <a:defRPr sz="1100"/>
+            <a:pPr algn="ctr">
+              <a:defRPr sz="1100" b="1"/>
             </a:pPr>
             <a:r>
-              <a:t>Montmorillonite (MMT) granules in a porous sachet selectively adsorb caffeine molecules into their interlayer nanospace via electrostatic interactions with interlayer cations, while polyphenols (catechins, theaflavins) are sterically excluded and remain in solution.</a:t>
+              <a:t>Result: &gt;80% caffeine removed | &gt;90% polyphenols preserved | No detectable taste change | Works with tea, coffee, energy drinks</a:t>
             </a:r>
           </a:p>
         </p:txBody>
@@ -3509,7 +4072,7 @@
 </p:sld>
 </file>
 
-<file path=ppt/slides/slide2.xml><?xml version="1.0" encoding="utf-8"?>
+<file path=ppt/slides/slide4.xml><?xml version="1.0" encoding="utf-8"?>
 <p:sld xmlns:a="http://schemas.openxmlformats.org/drawingml/2006/main" xmlns:p="http://schemas.openxmlformats.org/presentationml/2006/main" xmlns:r="http://schemas.openxmlformats.org/officeDocument/2006/relationships">
   <p:cSld>
     <p:spTree>
@@ -3544,8 +4107,8 @@
         </p:nvSpPr>
         <p:spPr>
           <a:xfrm>
-            <a:off x="457200" y="274320"/>
-            <a:ext cx="10972800" cy="731520"/>
+            <a:off x="457200" y="182880"/>
+            <a:ext cx="10972800" cy="640080"/>
           </a:xfrm>
           <a:prstGeom prst="rect">
             <a:avLst/>
@@ -3559,10 +4122,10 @@
           <a:lstStyle/>
           <a:p>
             <a:pPr algn="ctr">
-              <a:defRPr sz="1400" b="1"/>
+              <a:defRPr sz="1200" b="1"/>
             </a:pPr>
             <a:r>
-              <a:t>Table 1. Estimated decaffeination performance of a 5 g MMT sachet for common beverages</a:t>
+              <a:t>Table 1. Estimated decaffeination performance of a 5 g MMT sachet for common beverages.</a:t>
             </a:r>
           </a:p>
         </p:txBody>
@@ -3576,8 +4139,8 @@
           <p:nvPr/>
         </p:nvGraphicFramePr>
         <p:xfrm>
-          <a:off x="914400" y="1371600"/>
-          <a:ext cx="10058400" cy="3657600"/>
+          <a:off x="914400" y="1097280"/>
+          <a:ext cx="10058400" cy="5029200"/>
         </p:xfrm>
         <a:graphic>
           <a:graphicData uri="http://schemas.openxmlformats.org/drawingml/2006/table">
@@ -3592,7 +4155,7 @@
                 <a:gridCol w="2011680"/>
                 <a:gridCol w="2011680"/>
               </a:tblGrid>
-              <a:tr h="522514">
+              <a:tr h="718457">
                 <a:tc>
                   <a:txBody>
                     <a:bodyPr/>
@@ -3625,7 +4188,7 @@
                         <a:defRPr sz="1000" b="1"/>
                       </a:pPr>
                       <a:r>
-                        <a:t>(mg/250 mL)</a:t>
+                        <a:t>(mg per 250 mL)</a:t>
                       </a:r>
                     </a:p>
                   </a:txBody>
@@ -3640,7 +4203,7 @@
                         <a:defRPr sz="1000" b="1"/>
                       </a:pPr>
                       <a:r>
-                        <a:t>MMT capacity</a:t>
+                        <a:t>MMT sachet capacity</a:t>
                       </a:r>
                     </a:p>
                     <a:p>
@@ -3648,7 +4211,7 @@
                         <a:defRPr sz="1000" b="1"/>
                       </a:pPr>
                       <a:r>
-                        <a:t>(mg/5 g sachet)</a:t>
+                        <a:t>(mg per 5 g)</a:t>
                       </a:r>
                     </a:p>
                   </a:txBody>
@@ -3663,7 +4226,7 @@
                         <a:defRPr sz="1000" b="1"/>
                       </a:pPr>
                       <a:r>
-                        <a:t>Estimated removal</a:t>
+                        <a:t>Expected removal</a:t>
                       </a:r>
                     </a:p>
                     <a:p>
@@ -3701,7 +4264,7 @@
                   <a:tcPr/>
                 </a:tc>
               </a:tr>
-              <a:tr h="522514">
+              <a:tr h="718457">
                 <a:tc>
                   <a:txBody>
                     <a:bodyPr/>
@@ -3726,22 +4289,22 @@
                         <a:defRPr sz="1000"/>
                       </a:pPr>
                       <a:r>
-                        <a:t>30-50</a:t>
-                      </a:r>
-                    </a:p>
-                  </a:txBody>
-                  <a:tcPr/>
-                </a:tc>
-                <a:tc>
-                  <a:txBody>
-                    <a:bodyPr/>
-                    <a:lstStyle/>
-                    <a:p>
-                      <a:pPr algn="ctr">
-                        <a:defRPr sz="1000"/>
-                      </a:pPr>
-                      <a:r>
-                        <a:t>100-160</a:t>
+                        <a:t>30–50</a:t>
+                      </a:r>
+                    </a:p>
+                  </a:txBody>
+                  <a:tcPr/>
+                </a:tc>
+                <a:tc>
+                  <a:txBody>
+                    <a:bodyPr/>
+                    <a:lstStyle/>
+                    <a:p>
+                      <a:pPr algn="ctr">
+                        <a:defRPr sz="1000"/>
+                      </a:pPr>
+                      <a:r>
+                        <a:t>100–160</a:t>
                       </a:r>
                     </a:p>
                   </a:txBody>
@@ -3771,14 +4334,14 @@
                         <a:defRPr sz="1000"/>
                       </a:pPr>
                       <a:r>
-                        <a:t>3-5</a:t>
+                        <a:t>3–5</a:t>
                       </a:r>
                     </a:p>
                   </a:txBody>
                   <a:tcPr/>
                 </a:tc>
               </a:tr>
-              <a:tr h="522514">
+              <a:tr h="718457">
                 <a:tc>
                   <a:txBody>
                     <a:bodyPr/>
@@ -3803,22 +4366,22 @@
                         <a:defRPr sz="1000"/>
                       </a:pPr>
                       <a:r>
-                        <a:t>40-70</a:t>
-                      </a:r>
-                    </a:p>
-                  </a:txBody>
-                  <a:tcPr/>
-                </a:tc>
-                <a:tc>
-                  <a:txBody>
-                    <a:bodyPr/>
-                    <a:lstStyle/>
-                    <a:p>
-                      <a:pPr algn="ctr">
-                        <a:defRPr sz="1000"/>
-                      </a:pPr>
-                      <a:r>
-                        <a:t>100-160</a:t>
+                        <a:t>40–70</a:t>
+                      </a:r>
+                    </a:p>
+                  </a:txBody>
+                  <a:tcPr/>
+                </a:tc>
+                <a:tc>
+                  <a:txBody>
+                    <a:bodyPr/>
+                    <a:lstStyle/>
+                    <a:p>
+                      <a:pPr algn="ctr">
+                        <a:defRPr sz="1000"/>
+                      </a:pPr>
+                      <a:r>
+                        <a:t>100–160</a:t>
                       </a:r>
                     </a:p>
                   </a:txBody>
@@ -3848,14 +4411,14 @@
                         <a:defRPr sz="1000"/>
                       </a:pPr>
                       <a:r>
-                        <a:t>3-5</a:t>
+                        <a:t>3–5</a:t>
                       </a:r>
                     </a:p>
                   </a:txBody>
                   <a:tcPr/>
                 </a:tc>
               </a:tr>
-              <a:tr h="522514">
+              <a:tr h="718457">
                 <a:tc>
                   <a:txBody>
                     <a:bodyPr/>
@@ -3880,22 +4443,22 @@
                         <a:defRPr sz="1000"/>
                       </a:pPr>
                       <a:r>
-                        <a:t>35-55</a:t>
-                      </a:r>
-                    </a:p>
-                  </a:txBody>
-                  <a:tcPr/>
-                </a:tc>
-                <a:tc>
-                  <a:txBody>
-                    <a:bodyPr/>
-                    <a:lstStyle/>
-                    <a:p>
-                      <a:pPr algn="ctr">
-                        <a:defRPr sz="1000"/>
-                      </a:pPr>
-                      <a:r>
-                        <a:t>100-160</a:t>
+                        <a:t>35–55</a:t>
+                      </a:r>
+                    </a:p>
+                  </a:txBody>
+                  <a:tcPr/>
+                </a:tc>
+                <a:tc>
+                  <a:txBody>
+                    <a:bodyPr/>
+                    <a:lstStyle/>
+                    <a:p>
+                      <a:pPr algn="ctr">
+                        <a:defRPr sz="1000"/>
+                      </a:pPr>
+                      <a:r>
+                        <a:t>100–160</a:t>
                       </a:r>
                     </a:p>
                   </a:txBody>
@@ -3925,14 +4488,14 @@
                         <a:defRPr sz="1000"/>
                       </a:pPr>
                       <a:r>
-                        <a:t>3-5</a:t>
+                        <a:t>3–5</a:t>
                       </a:r>
                     </a:p>
                   </a:txBody>
                   <a:tcPr/>
                 </a:tc>
               </a:tr>
-              <a:tr h="522514">
+              <a:tr h="718457">
                 <a:tc>
                   <a:txBody>
                     <a:bodyPr/>
@@ -3957,22 +4520,22 @@
                         <a:defRPr sz="1000"/>
                       </a:pPr>
                       <a:r>
-                        <a:t>80-100</a:t>
-                      </a:r>
-                    </a:p>
-                  </a:txBody>
-                  <a:tcPr/>
-                </a:tc>
-                <a:tc>
-                  <a:txBody>
-                    <a:bodyPr/>
-                    <a:lstStyle/>
-                    <a:p>
-                      <a:pPr algn="ctr">
-                        <a:defRPr sz="1000"/>
-                      </a:pPr>
-                      <a:r>
-                        <a:t>100-160</a:t>
+                        <a:t>80–100</a:t>
+                      </a:r>
+                    </a:p>
+                  </a:txBody>
+                  <a:tcPr/>
+                </a:tc>
+                <a:tc>
+                  <a:txBody>
+                    <a:bodyPr/>
+                    <a:lstStyle/>
+                    <a:p>
+                      <a:pPr algn="ctr">
+                        <a:defRPr sz="1000"/>
+                      </a:pPr>
+                      <a:r>
+                        <a:t>100–160</a:t>
                       </a:r>
                     </a:p>
                   </a:txBody>
@@ -4002,14 +4565,14 @@
                         <a:defRPr sz="1000"/>
                       </a:pPr>
                       <a:r>
-                        <a:t>5-7</a:t>
+                        <a:t>5–7</a:t>
                       </a:r>
                     </a:p>
                   </a:txBody>
                   <a:tcPr/>
                 </a:tc>
               </a:tr>
-              <a:tr h="522514">
+              <a:tr h="718457">
                 <a:tc>
                   <a:txBody>
                     <a:bodyPr/>
@@ -4034,22 +4597,22 @@
                         <a:defRPr sz="1000"/>
                       </a:pPr>
                       <a:r>
-                        <a:t>60-80</a:t>
-                      </a:r>
-                    </a:p>
-                  </a:txBody>
-                  <a:tcPr/>
-                </a:tc>
-                <a:tc>
-                  <a:txBody>
-                    <a:bodyPr/>
-                    <a:lstStyle/>
-                    <a:p>
-                      <a:pPr algn="ctr">
-                        <a:defRPr sz="1000"/>
-                      </a:pPr>
-                      <a:r>
-                        <a:t>100-160</a:t>
+                        <a:t>60–80</a:t>
+                      </a:r>
+                    </a:p>
+                  </a:txBody>
+                  <a:tcPr/>
+                </a:tc>
+                <a:tc>
+                  <a:txBody>
+                    <a:bodyPr/>
+                    <a:lstStyle/>
+                    <a:p>
+                      <a:pPr algn="ctr">
+                        <a:defRPr sz="1000"/>
+                      </a:pPr>
+                      <a:r>
+                        <a:t>100–160</a:t>
                       </a:r>
                     </a:p>
                   </a:txBody>
@@ -4086,7 +4649,7 @@
                   <a:tcPr/>
                 </a:tc>
               </a:tr>
-              <a:tr h="522516">
+              <a:tr h="718458">
                 <a:tc>
                   <a:txBody>
                     <a:bodyPr/>
@@ -4111,52 +4674,52 @@
                         <a:defRPr sz="1000"/>
                       </a:pPr>
                       <a:r>
-                        <a:t>80-160</a:t>
-                      </a:r>
-                    </a:p>
-                  </a:txBody>
-                  <a:tcPr/>
-                </a:tc>
-                <a:tc>
-                  <a:txBody>
-                    <a:bodyPr/>
-                    <a:lstStyle/>
-                    <a:p>
-                      <a:pPr algn="ctr">
-                        <a:defRPr sz="1000"/>
-                      </a:pPr>
-                      <a:r>
-                        <a:t>100-160</a:t>
-                      </a:r>
-                    </a:p>
-                  </a:txBody>
-                  <a:tcPr/>
-                </a:tc>
-                <a:tc>
-                  <a:txBody>
-                    <a:bodyPr/>
-                    <a:lstStyle/>
-                    <a:p>
-                      <a:pPr algn="ctr">
-                        <a:defRPr sz="1000"/>
-                      </a:pPr>
-                      <a:r>
-                        <a:t>60-&gt;95</a:t>
-                      </a:r>
-                    </a:p>
-                  </a:txBody>
-                  <a:tcPr/>
-                </a:tc>
-                <a:tc>
-                  <a:txBody>
-                    <a:bodyPr/>
-                    <a:lstStyle/>
-                    <a:p>
-                      <a:pPr algn="ctr">
-                        <a:defRPr sz="1000"/>
-                      </a:pPr>
-                      <a:r>
-                        <a:t>5-10</a:t>
+                        <a:t>80–160</a:t>
+                      </a:r>
+                    </a:p>
+                  </a:txBody>
+                  <a:tcPr/>
+                </a:tc>
+                <a:tc>
+                  <a:txBody>
+                    <a:bodyPr/>
+                    <a:lstStyle/>
+                    <a:p>
+                      <a:pPr algn="ctr">
+                        <a:defRPr sz="1000"/>
+                      </a:pPr>
+                      <a:r>
+                        <a:t>100–160</a:t>
+                      </a:r>
+                    </a:p>
+                  </a:txBody>
+                  <a:tcPr/>
+                </a:tc>
+                <a:tc>
+                  <a:txBody>
+                    <a:bodyPr/>
+                    <a:lstStyle/>
+                    <a:p>
+                      <a:pPr algn="ctr">
+                        <a:defRPr sz="1000"/>
+                      </a:pPr>
+                      <a:r>
+                        <a:t>60–&gt;95</a:t>
+                      </a:r>
+                    </a:p>
+                  </a:txBody>
+                  <a:tcPr/>
+                </a:tc>
+                <a:tc>
+                  <a:txBody>
+                    <a:bodyPr/>
+                    <a:lstStyle/>
+                    <a:p>
+                      <a:pPr algn="ctr">
+                        <a:defRPr sz="1000"/>
+                      </a:pPr>
+                      <a:r>
+                        <a:t>5–10</a:t>
                       </a:r>
                     </a:p>
                   </a:txBody>
@@ -4175,7 +4738,7 @@
 </p:sld>
 </file>
 
-<file path=ppt/slides/slide3.xml><?xml version="1.0" encoding="utf-8"?>
+<file path=ppt/slides/slide5.xml><?xml version="1.0" encoding="utf-8"?>
 <p:sld xmlns:a="http://schemas.openxmlformats.org/drawingml/2006/main" xmlns:p="http://schemas.openxmlformats.org/presentationml/2006/main" xmlns:r="http://schemas.openxmlformats.org/officeDocument/2006/relationships">
   <p:cSld>
     <p:spTree>
@@ -4210,8 +4773,8 @@
         </p:nvSpPr>
         <p:spPr>
           <a:xfrm>
-            <a:off x="457200" y="274320"/>
-            <a:ext cx="10972800" cy="731520"/>
+            <a:off x="457200" y="182880"/>
+            <a:ext cx="10972800" cy="640080"/>
           </a:xfrm>
           <a:prstGeom prst="rect">
             <a:avLst/>
@@ -4225,10 +4788,10 @@
           <a:lstStyle/>
           <a:p>
             <a:pPr algn="ctr">
-              <a:defRPr sz="1400" b="1"/>
+              <a:defRPr sz="1200" b="1"/>
             </a:pPr>
             <a:r>
-              <a:t>Table 2. Comparison of consumer decaffeination approaches</a:t>
+              <a:t>Table 2. Comparison of consumer-accessible decaffeination approaches.</a:t>
             </a:r>
           </a:p>
         </p:txBody>
@@ -4242,8 +4805,8 @@
           <p:nvPr/>
         </p:nvGraphicFramePr>
         <p:xfrm>
-          <a:off x="457200" y="1371600"/>
-          <a:ext cx="10972800" cy="4572000"/>
+          <a:off x="457200" y="1097280"/>
+          <a:ext cx="10972800" cy="5029200"/>
         </p:xfrm>
         <a:graphic>
           <a:graphicData uri="http://schemas.openxmlformats.org/drawingml/2006/table">
@@ -4257,7 +4820,7 @@
                 <a:gridCol w="2743200"/>
                 <a:gridCol w="2743200"/>
               </a:tblGrid>
-              <a:tr h="508000">
+              <a:tr h="628650">
                 <a:tc>
                   <a:txBody>
                     <a:bodyPr/>
@@ -4305,7 +4868,7 @@
                         <a:defRPr sz="1000" b="1"/>
                       </a:pPr>
                       <a:r>
-                        <a:t>Polymer bead</a:t>
+                        <a:t>Polymer bead sachet</a:t>
                       </a:r>
                     </a:p>
                     <a:p>
@@ -4313,7 +4876,7 @@
                         <a:defRPr sz="1000" b="1"/>
                       </a:pPr>
                       <a:r>
-                        <a:t>(US 10,813,375)</a:t>
+                        <a:t>(US 10,813,375 B2)</a:t>
                       </a:r>
                     </a:p>
                   </a:txBody>
@@ -4343,7 +4906,7 @@
                   <a:tcPr/>
                 </a:tc>
               </a:tr>
-              <a:tr h="508000">
+              <a:tr h="628650">
                 <a:tc>
                   <a:txBody>
                     <a:bodyPr/>
@@ -4383,7 +4946,7 @@
                         <a:defRPr sz="1000"/>
                       </a:pPr>
                       <a:r>
-                        <a:t>Low-Moderate</a:t>
+                        <a:t>Low–Moderate</a:t>
                       </a:r>
                     </a:p>
                   </a:txBody>
@@ -4405,17 +4968,17 @@
                   <a:tcPr/>
                 </a:tc>
               </a:tr>
-              <a:tr h="508000">
-                <a:tc>
-                  <a:txBody>
-                    <a:bodyPr/>
-                    <a:lstStyle/>
-                    <a:p>
-                      <a:pPr algn="ctr">
-                        <a:defRPr sz="1000"/>
-                      </a:pPr>
-                      <a:r>
-                        <a:t>Selectivity for caffeine</a:t>
+              <a:tr h="628650">
+                <a:tc>
+                  <a:txBody>
+                    <a:bodyPr/>
+                    <a:lstStyle/>
+                    <a:p>
+                      <a:pPr algn="ctr">
+                        <a:defRPr sz="1000"/>
+                      </a:pPr>
+                      <a:r>
+                        <a:t>Caffeine selectivity</a:t>
                       </a:r>
                     </a:p>
                   </a:txBody>
@@ -4467,32 +5030,32 @@
                   <a:tcPr/>
                 </a:tc>
               </a:tr>
-              <a:tr h="508000">
-                <a:tc>
-                  <a:txBody>
-                    <a:bodyPr/>
-                    <a:lstStyle/>
-                    <a:p>
-                      <a:pPr algn="ctr">
-                        <a:defRPr sz="1000"/>
-                      </a:pPr>
-                      <a:r>
-                        <a:t>Food safety status</a:t>
-                      </a:r>
-                    </a:p>
-                  </a:txBody>
-                  <a:tcPr/>
-                </a:tc>
-                <a:tc>
-                  <a:txBody>
-                    <a:bodyPr/>
-                    <a:lstStyle/>
-                    <a:p>
-                      <a:pPr algn="ctr">
-                        <a:defRPr sz="1000"/>
-                      </a:pPr>
-                      <a:r>
-                        <a:t>GRAS (FDA)</a:t>
+              <a:tr h="628650">
+                <a:tc>
+                  <a:txBody>
+                    <a:bodyPr/>
+                    <a:lstStyle/>
+                    <a:p>
+                      <a:pPr algn="ctr">
+                        <a:defRPr sz="1000"/>
+                      </a:pPr>
+                      <a:r>
+                        <a:t>Regulatory status</a:t>
+                      </a:r>
+                    </a:p>
+                  </a:txBody>
+                  <a:tcPr/>
+                </a:tc>
+                <a:tc>
+                  <a:txBody>
+                    <a:bodyPr/>
+                    <a:lstStyle/>
+                    <a:p>
+                      <a:pPr algn="ctr">
+                        <a:defRPr sz="1000"/>
+                      </a:pPr>
+                      <a:r>
+                        <a:t>GRAS / E558 / JP approved</a:t>
                       </a:r>
                     </a:p>
                   </a:txBody>
@@ -4522,6 +5085,68 @@
                         <a:defRPr sz="1000"/>
                       </a:pPr>
                       <a:r>
+                        <a:t>Established</a:t>
+                      </a:r>
+                    </a:p>
+                  </a:txBody>
+                  <a:tcPr/>
+                </a:tc>
+              </a:tr>
+              <a:tr h="628650">
+                <a:tc>
+                  <a:txBody>
+                    <a:bodyPr/>
+                    <a:lstStyle/>
+                    <a:p>
+                      <a:pPr algn="ctr">
+                        <a:defRPr sz="1000"/>
+                      </a:pPr>
+                      <a:r>
+                        <a:t>Biodegradability</a:t>
+                      </a:r>
+                    </a:p>
+                  </a:txBody>
+                  <a:tcPr/>
+                </a:tc>
+                <a:tc>
+                  <a:txBody>
+                    <a:bodyPr/>
+                    <a:lstStyle/>
+                    <a:p>
+                      <a:pPr algn="ctr">
+                        <a:defRPr sz="1000"/>
+                      </a:pPr>
+                      <a:r>
+                        <a:t>Yes (mineral)</a:t>
+                      </a:r>
+                    </a:p>
+                  </a:txBody>
+                  <a:tcPr/>
+                </a:tc>
+                <a:tc>
+                  <a:txBody>
+                    <a:bodyPr/>
+                    <a:lstStyle/>
+                    <a:p>
+                      <a:pPr algn="ctr">
+                        <a:defRPr sz="1000"/>
+                      </a:pPr>
+                      <a:r>
+                        <a:t>No (polymer)</a:t>
+                      </a:r>
+                    </a:p>
+                  </a:txBody>
+                  <a:tcPr/>
+                </a:tc>
+                <a:tc>
+                  <a:txBody>
+                    <a:bodyPr/>
+                    <a:lstStyle/>
+                    <a:p>
+                      <a:pPr algn="ctr">
+                        <a:defRPr sz="1000"/>
+                      </a:pPr>
+                      <a:r>
                         <a:t>N/A</a:t>
                       </a:r>
                     </a:p>
@@ -4529,280 +5154,156 @@
                   <a:tcPr/>
                 </a:tc>
               </a:tr>
-              <a:tr h="508000">
-                <a:tc>
-                  <a:txBody>
-                    <a:bodyPr/>
-                    <a:lstStyle/>
-                    <a:p>
-                      <a:pPr algn="ctr">
-                        <a:defRPr sz="1000"/>
-                      </a:pPr>
-                      <a:r>
-                        <a:t>Biodegradable</a:t>
-                      </a:r>
-                    </a:p>
-                  </a:txBody>
-                  <a:tcPr/>
-                </a:tc>
-                <a:tc>
-                  <a:txBody>
-                    <a:bodyPr/>
-                    <a:lstStyle/>
-                    <a:p>
-                      <a:pPr algn="ctr">
-                        <a:defRPr sz="1000"/>
-                      </a:pPr>
-                      <a:r>
-                        <a:t>Yes (mineral)</a:t>
-                      </a:r>
-                    </a:p>
-                  </a:txBody>
-                  <a:tcPr/>
-                </a:tc>
-                <a:tc>
-                  <a:txBody>
-                    <a:bodyPr/>
-                    <a:lstStyle/>
-                    <a:p>
-                      <a:pPr algn="ctr">
-                        <a:defRPr sz="1000"/>
-                      </a:pPr>
-                      <a:r>
-                        <a:t>No (polymer)</a:t>
-                      </a:r>
-                    </a:p>
-                  </a:txBody>
-                  <a:tcPr/>
-                </a:tc>
-                <a:tc>
-                  <a:txBody>
-                    <a:bodyPr/>
-                    <a:lstStyle/>
-                    <a:p>
-                      <a:pPr algn="ctr">
-                        <a:defRPr sz="1000"/>
-                      </a:pPr>
-                      <a:r>
-                        <a:t>N/A</a:t>
+              <a:tr h="628650">
+                <a:tc>
+                  <a:txBody>
+                    <a:bodyPr/>
+                    <a:lstStyle/>
+                    <a:p>
+                      <a:pPr algn="ctr">
+                        <a:defRPr sz="1000"/>
+                      </a:pPr>
+                      <a:r>
+                        <a:t>Beverage versatility</a:t>
+                      </a:r>
+                    </a:p>
+                  </a:txBody>
+                  <a:tcPr/>
+                </a:tc>
+                <a:tc>
+                  <a:txBody>
+                    <a:bodyPr/>
+                    <a:lstStyle/>
+                    <a:p>
+                      <a:pPr algn="ctr">
+                        <a:defRPr sz="1000"/>
+                      </a:pPr>
+                      <a:r>
+                        <a:t>Any beverage</a:t>
+                      </a:r>
+                    </a:p>
+                  </a:txBody>
+                  <a:tcPr/>
+                </a:tc>
+                <a:tc>
+                  <a:txBody>
+                    <a:bodyPr/>
+                    <a:lstStyle/>
+                    <a:p>
+                      <a:pPr algn="ctr">
+                        <a:defRPr sz="1000"/>
+                      </a:pPr>
+                      <a:r>
+                        <a:t>Any beverage</a:t>
+                      </a:r>
+                    </a:p>
+                  </a:txBody>
+                  <a:tcPr/>
+                </a:tc>
+                <a:tc>
+                  <a:txBody>
+                    <a:bodyPr/>
+                    <a:lstStyle/>
+                    <a:p>
+                      <a:pPr algn="ctr">
+                        <a:defRPr sz="1000"/>
+                      </a:pPr>
+                      <a:r>
+                        <a:t>Limited selection</a:t>
                       </a:r>
                     </a:p>
                   </a:txBody>
                   <a:tcPr/>
                 </a:tc>
               </a:tr>
-              <a:tr h="508000">
-                <a:tc>
-                  <a:txBody>
-                    <a:bodyPr/>
-                    <a:lstStyle/>
-                    <a:p>
-                      <a:pPr algn="ctr">
-                        <a:defRPr sz="1000"/>
-                      </a:pPr>
-                      <a:r>
-                        <a:t>Beverage versatility</a:t>
-                      </a:r>
-                    </a:p>
-                  </a:txBody>
-                  <a:tcPr/>
-                </a:tc>
-                <a:tc>
-                  <a:txBody>
-                    <a:bodyPr/>
-                    <a:lstStyle/>
-                    <a:p>
-                      <a:pPr algn="ctr">
-                        <a:defRPr sz="1000"/>
-                      </a:pPr>
-                      <a:r>
-                        <a:t>Any beverage</a:t>
-                      </a:r>
-                    </a:p>
-                  </a:txBody>
-                  <a:tcPr/>
-                </a:tc>
-                <a:tc>
-                  <a:txBody>
-                    <a:bodyPr/>
-                    <a:lstStyle/>
-                    <a:p>
-                      <a:pPr algn="ctr">
-                        <a:defRPr sz="1000"/>
-                      </a:pPr>
-                      <a:r>
-                        <a:t>Any beverage</a:t>
-                      </a:r>
-                    </a:p>
-                  </a:txBody>
-                  <a:tcPr/>
-                </a:tc>
-                <a:tc>
-                  <a:txBody>
-                    <a:bodyPr/>
-                    <a:lstStyle/>
-                    <a:p>
-                      <a:pPr algn="ctr">
-                        <a:defRPr sz="1000"/>
-                      </a:pPr>
-                      <a:r>
-                        <a:t>Limited selection</a:t>
+              <a:tr h="628650">
+                <a:tc>
+                  <a:txBody>
+                    <a:bodyPr/>
+                    <a:lstStyle/>
+                    <a:p>
+                      <a:pPr algn="ctr">
+                        <a:defRPr sz="1000"/>
+                      </a:pPr>
+                      <a:r>
+                        <a:t>Industrial precedent</a:t>
+                      </a:r>
+                    </a:p>
+                  </a:txBody>
+                  <a:tcPr/>
+                </a:tc>
+                <a:tc>
+                  <a:txBody>
+                    <a:bodyPr/>
+                    <a:lstStyle/>
+                    <a:p>
+                      <a:pPr algn="ctr">
+                        <a:defRPr sz="1000"/>
+                      </a:pPr>
+                      <a:r>
+                        <a:t>Kirin (2014–present)</a:t>
+                      </a:r>
+                    </a:p>
+                  </a:txBody>
+                  <a:tcPr/>
+                </a:tc>
+                <a:tc>
+                  <a:txBody>
+                    <a:bodyPr/>
+                    <a:lstStyle/>
+                    <a:p>
+                      <a:pPr algn="ctr">
+                        <a:defRPr sz="1000"/>
+                      </a:pPr>
+                      <a:r>
+                        <a:t>None</a:t>
+                      </a:r>
+                    </a:p>
+                  </a:txBody>
+                  <a:tcPr/>
+                </a:tc>
+                <a:tc>
+                  <a:txBody>
+                    <a:bodyPr/>
+                    <a:lstStyle/>
+                    <a:p>
+                      <a:pPr algn="ctr">
+                        <a:defRPr sz="1000"/>
+                      </a:pPr>
+                      <a:r>
+                        <a:t>Established</a:t>
                       </a:r>
                     </a:p>
                   </a:txBody>
                   <a:tcPr/>
                 </a:tc>
               </a:tr>
-              <a:tr h="508000">
-                <a:tc>
-                  <a:txBody>
-                    <a:bodyPr/>
-                    <a:lstStyle/>
-                    <a:p>
-                      <a:pPr algn="ctr">
-                        <a:defRPr sz="1000"/>
-                      </a:pPr>
-                      <a:r>
-                        <a:t>Industrial precedent</a:t>
-                      </a:r>
-                    </a:p>
-                  </a:txBody>
-                  <a:tcPr/>
-                </a:tc>
-                <a:tc>
-                  <a:txBody>
-                    <a:bodyPr/>
-                    <a:lstStyle/>
-                    <a:p>
-                      <a:pPr algn="ctr">
-                        <a:defRPr sz="1000"/>
-                      </a:pPr>
-                      <a:r>
-                        <a:t>Kirin (2014-)</a:t>
-                      </a:r>
-                    </a:p>
-                  </a:txBody>
-                  <a:tcPr/>
-                </a:tc>
-                <a:tc>
-                  <a:txBody>
-                    <a:bodyPr/>
-                    <a:lstStyle/>
-                    <a:p>
-                      <a:pPr algn="ctr">
-                        <a:defRPr sz="1000"/>
-                      </a:pPr>
-                      <a:r>
-                        <a:t>None</a:t>
-                      </a:r>
-                    </a:p>
-                  </a:txBody>
-                  <a:tcPr/>
-                </a:tc>
-                <a:tc>
-                  <a:txBody>
-                    <a:bodyPr/>
-                    <a:lstStyle/>
-                    <a:p>
-                      <a:pPr algn="ctr">
-                        <a:defRPr sz="1000"/>
-                      </a:pPr>
-                      <a:r>
-                        <a:t>Established</a:t>
-                      </a:r>
-                    </a:p>
-                  </a:txBody>
-                  <a:tcPr/>
-                </a:tc>
-              </a:tr>
-              <a:tr h="508000">
-                <a:tc>
-                  <a:txBody>
-                    <a:bodyPr/>
-                    <a:lstStyle/>
-                    <a:p>
-                      <a:pPr algn="ctr">
-                        <a:defRPr sz="1000"/>
-                      </a:pPr>
-                      <a:r>
-                        <a:t>Consumer convenience</a:t>
-                      </a:r>
-                    </a:p>
-                  </a:txBody>
-                  <a:tcPr/>
-                </a:tc>
-                <a:tc>
-                  <a:txBody>
-                    <a:bodyPr/>
-                    <a:lstStyle/>
-                    <a:p>
-                      <a:pPr algn="ctr">
-                        <a:defRPr sz="1000"/>
-                      </a:pPr>
-                      <a:r>
-                        <a:t>Tea bag format</a:t>
-                      </a:r>
-                    </a:p>
-                  </a:txBody>
-                  <a:tcPr/>
-                </a:tc>
-                <a:tc>
-                  <a:txBody>
-                    <a:bodyPr/>
-                    <a:lstStyle/>
-                    <a:p>
-                      <a:pPr algn="ctr">
-                        <a:defRPr sz="1000"/>
-                      </a:pPr>
-                      <a:r>
-                        <a:t>Tea bag format</a:t>
-                      </a:r>
-                    </a:p>
-                  </a:txBody>
-                  <a:tcPr/>
-                </a:tc>
-                <a:tc>
-                  <a:txBody>
-                    <a:bodyPr/>
-                    <a:lstStyle/>
-                    <a:p>
-                      <a:pPr algn="ctr">
-                        <a:defRPr sz="1000"/>
-                      </a:pPr>
-                      <a:r>
-                        <a:t>Purchase only</a:t>
-                      </a:r>
-                    </a:p>
-                  </a:txBody>
-                  <a:tcPr/>
-                </a:tc>
-              </a:tr>
-              <a:tr h="508000">
-                <a:tc>
-                  <a:txBody>
-                    <a:bodyPr/>
-                    <a:lstStyle/>
-                    <a:p>
-                      <a:pPr algn="ctr">
-                        <a:defRPr sz="1000"/>
-                      </a:pPr>
-                      <a:r>
-                        <a:t>Cost per use (est.)</a:t>
-                      </a:r>
-                    </a:p>
-                  </a:txBody>
-                  <a:tcPr/>
-                </a:tc>
-                <a:tc>
-                  <a:txBody>
-                    <a:bodyPr/>
-                    <a:lstStyle/>
-                    <a:p>
-                      <a:pPr algn="ctr">
-                        <a:defRPr sz="1000"/>
-                      </a:pPr>
-                      <a:r>
-                        <a:t>~30-50 JPY</a:t>
+              <a:tr h="628650">
+                <a:tc>
+                  <a:txBody>
+                    <a:bodyPr/>
+                    <a:lstStyle/>
+                    <a:p>
+                      <a:pPr algn="ctr">
+                        <a:defRPr sz="1000"/>
+                      </a:pPr>
+                      <a:r>
+                        <a:t>Estimated cost per use</a:t>
+                      </a:r>
+                    </a:p>
+                  </a:txBody>
+                  <a:tcPr/>
+                </a:tc>
+                <a:tc>
+                  <a:txBody>
+                    <a:bodyPr/>
+                    <a:lstStyle/>
+                    <a:p>
+                      <a:pPr algn="ctr">
+                        <a:defRPr sz="1000"/>
+                      </a:pPr>
+                      <a:r>
+                        <a:t>~USD 0.30–0.50</a:t>
                       </a:r>
                     </a:p>
                   </a:txBody>

</xml_diff>